<commit_message>
memory: regen views (session hook)
</commit_message>
<xml_diff>
--- a/projects/WaferEngine-staging/meetings/2026-07-26.pptx
+++ b/projects/WaferEngine-staging/meetings/2026-07-26.pptx
@@ -656,7 +656,7 @@
           <a:lstStyle/>
           <a:p>
             <a:r>
-              <a:t>The two effects cannot be switched on and off independently in the kernel: dropping the picking stage without also dropping the drain that feeds it unbalances the fabric and hangs. So they have to be told apart by the shape of the curve on the next slide.</a:t>
+              <a:t>Both effects are real, but they are not the same size. The next slide shows the measurement that separates them.</a:t>
             </a:r>
           </a:p>
         </p:txBody>
@@ -702,7 +702,7 @@
           <a:lstStyle/>
           <a:p>
             <a:r>
-              <a:t>Same configuration, pipelined against non-pipelined, was 17,149 to 13,096 cycles per token, a 24% saving. Correctness held at 9.8e-5 against the oracle.</a:t>
+              <a:t>Left: if the saving were skipped work, the ratio would climb toward 100% as the context grows and attention dwarfs the skipped stage. It does not move. Right: holding the model fixed and spreading it over more blocks tracks the predicted ratio at all three points.</a:t>
             </a:r>
           </a:p>
         </p:txBody>
@@ -1278,7 +1278,7 @@
                 </a:solidFill>
                 <a:latin typeface="Arial"/>
               </a:rPr>
-              <a:t>S6 closes M0's reuse line. M1 opens on holding several requests at once.</a:t>
+              <a:t>S6 closes M0's reuse line. Force-decode turns out to be 8.5x cheaper on the wafer, for a reason we had wrong.</a:t>
             </a:r>
           </a:p>
         </p:txBody>
@@ -1772,7 +1772,7 @@
                 </a:solidFill>
                 <a:latin typeface="Arial"/>
               </a:rPr>
-              <a:t>FORCE-DECODE, SIMULATOR</a:t>
+              <a:t>FORCE-DECODE, REAL WSE-3</a:t>
             </a:r>
           </a:p>
         </p:txBody>
@@ -1811,14 +1811,14 @@
                 </a:solidFill>
                 <a:latin typeface="Arial"/>
               </a:rPr>
-              <a:t>The line is straight, so it is skipped work, not overlap</a:t>
+              <a:t>The win is layer overlap, and the formula predicts it</a:t>
             </a:r>
           </a:p>
         </p:txBody>
       </p:sp>
       <p:pic>
         <p:nvPicPr>
-          <p:cNvPr id="4" name="figure" descr="fig_fsweep.png"/>
+          <p:cNvPr id="4" name="figure" descr="fig_verdict.png"/>
           <p:cNvPicPr>
             <a:picLocks noChangeAspect="1"/>
           </p:cNvPicPr>
@@ -1832,8 +1832,8 @@
         </p:blipFill>
         <p:spPr>
           <a:xfrm>
-            <a:off x="2430276" y="2484882"/>
-            <a:ext cx="13427446" cy="5271516"/>
+            <a:off x="2651899" y="2484882"/>
+            <a:ext cx="12984200" cy="4944618"/>
           </a:xfrm>
           <a:prstGeom prst="rect">
             <a:avLst/>
@@ -1848,8 +1848,8 @@
         </p:nvSpPr>
         <p:spPr>
           <a:xfrm>
-            <a:off x="987552" y="8030718"/>
-            <a:ext cx="16312896" cy="326898"/>
+            <a:off x="987552" y="7703820"/>
+            <a:ext cx="16312896" cy="653796"/>
           </a:xfrm>
           <a:prstGeom prst="rect">
             <a:avLst/>
@@ -1874,7 +1874,7 @@
                 </a:solidFill>
                 <a:latin typeface="Arial"/>
               </a:rPr>
-              <a:t>Toy layout: 2x2 blocks, width 64, vocabulary 24. A forced step costs about 28% of a plain step here, roughly 806 cycles against 2,856.</a:t>
+              <a:t>A forced token costs about 12% of a plain one, roughly 8.5 times cheaper. 524,288 PEs, 28 layers over 8 blocks, vocabulary 151,936. Device runs are timing-only.</a:t>
             </a:r>
           </a:p>
         </p:txBody>
@@ -1970,7 +1970,7 @@
                 </a:solidFill>
                 <a:latin typeface="Arial"/>
               </a:rPr>
-              <a:t>This partly falsified what we expected</a:t>
+              <a:t>We had this backwards a week ago</a:t>
             </a:r>
           </a:p>
         </p:txBody>
@@ -2028,7 +2028,7 @@
         <p:spPr>
           <a:xfrm>
             <a:off x="1353312" y="2484882"/>
-            <a:ext cx="15947136" cy="804672"/>
+            <a:ext cx="15947136" cy="402336"/>
           </a:xfrm>
           <a:prstGeom prst="rect">
             <a:avLst/>
@@ -2053,7 +2053,7 @@
                 </a:solidFill>
                 <a:latin typeface="Arial"/>
               </a:rPr>
-              <a:t>We expected the gain to come from layer pipelining: forced tokens let the front of the model run ahead and fill the pipeline.</a:t>
+              <a:t>Last week we said the saving was skipped work. That is now falsified, not narrowed: on the wafer it is layer overlap.</a:t>
             </a:r>
           </a:p>
         </p:txBody>
@@ -2066,7 +2066,7 @@
         </p:nvSpPr>
         <p:spPr>
           <a:xfrm>
-            <a:off x="987552" y="3728465"/>
+            <a:off x="987552" y="3326129"/>
             <a:ext cx="109728" cy="109728"/>
           </a:xfrm>
           <a:prstGeom prst="ellipse">
@@ -2110,8 +2110,8 @@
         </p:nvSpPr>
         <p:spPr>
           <a:xfrm>
-            <a:off x="1353312" y="3600450"/>
-            <a:ext cx="15947136" cy="804672"/>
+            <a:off x="1353312" y="3198113"/>
+            <a:ext cx="15947136" cy="402336"/>
           </a:xfrm>
           <a:prstGeom prst="rect">
             <a:avLst/>
@@ -2136,7 +2136,7 @@
                 </a:solidFill>
                 <a:latin typeface="Arial"/>
               </a:rPr>
-              <a:t>A straight line rules that out. Pipelining would flatten once the pipeline is full; a constant saving per forced step means work is simply not being done.</a:t>
+              <a:t>The old test could not have decided it. Once forced steps run open-loop, both explanations predict a straight line.</a:t>
             </a:r>
           </a:p>
         </p:txBody>
@@ -2149,7 +2149,7 @@
         </p:nvSpPr>
         <p:spPr>
           <a:xfrm>
-            <a:off x="987552" y="4844033"/>
+            <a:off x="987552" y="4039361"/>
             <a:ext cx="109728" cy="109728"/>
           </a:xfrm>
           <a:prstGeom prst="ellipse">
@@ -2193,7 +2193,7 @@
         </p:nvSpPr>
         <p:spPr>
           <a:xfrm>
-            <a:off x="1353312" y="4716018"/>
+            <a:off x="1353312" y="3911346"/>
             <a:ext cx="15947136" cy="402336"/>
           </a:xfrm>
           <a:prstGeom prst="rect">
@@ -2219,7 +2219,7 @@
                 </a:solidFill>
                 <a:latin typeface="Arial"/>
               </a:rPr>
-              <a:t>Each forced step drops its sampling and output-projection stage, and that should grow with a real 128k vocabulary.</a:t>
+              <a:t>The magnitudes never fitted either. The skipped stage is about 5% of a step, yet the saving was about 71%.</a:t>
             </a:r>
           </a:p>
         </p:txBody>
@@ -2232,7 +2232,7 @@
         </p:nvSpPr>
         <p:spPr>
           <a:xfrm>
-            <a:off x="987552" y="5557266"/>
+            <a:off x="987552" y="4752594"/>
             <a:ext cx="109728" cy="109728"/>
           </a:xfrm>
           <a:prstGeom prst="ellipse">
@@ -2276,7 +2276,90 @@
         </p:nvSpPr>
         <p:spPr>
           <a:xfrm>
-            <a:off x="1353312" y="5429250"/>
+            <a:off x="1353312" y="4624578"/>
+            <a:ext cx="15947136" cy="804672"/>
+          </a:xfrm>
+          <a:prstGeom prst="rect">
+            <a:avLst/>
+          </a:prstGeom>
+          <a:noFill/>
+        </p:spPr>
+        <p:txBody>
+          <a:bodyPr wrap="square" lIns="0" rIns="0" tIns="0" bIns="0" anchor="t">
+            <a:spAutoFit/>
+          </a:bodyPr>
+          <a:lstStyle/>
+          <a:p>
+            <a:pPr algn="l">
+              <a:lnSpc>
+                <a:spcPct val="132000"/>
+              </a:lnSpc>
+            </a:pPr>
+            <a:r>
+              <a:rPr sz="2400" b="0" u="none" i="0">
+                <a:solidFill>
+                  <a:srgbClr val="18181B"/>
+                </a:solidFill>
+                <a:latin typeface="Arial"/>
+              </a:rPr>
+              <a:t>The size of the win is set by how the layers are spread across the block pipeline, not by vocabulary as we had predicted.</a:t>
+            </a:r>
+          </a:p>
+        </p:txBody>
+      </p:sp>
+      <p:sp>
+        <p:nvSpPr>
+          <p:cNvPr id="12" name="dot"/>
+          <p:cNvSpPr/>
+          <p:nvPr/>
+        </p:nvSpPr>
+        <p:spPr>
+          <a:xfrm>
+            <a:off x="987552" y="5868162"/>
+            <a:ext cx="109728" cy="109728"/>
+          </a:xfrm>
+          <a:prstGeom prst="ellipse">
+            <a:avLst/>
+          </a:prstGeom>
+          <a:solidFill>
+            <a:srgbClr val="6D28D9"/>
+          </a:solidFill>
+          <a:ln>
+            <a:noFill/>
+          </a:ln>
+          <a:effectLst/>
+        </p:spPr>
+        <p:style>
+          <a:lnRef idx="1">
+            <a:schemeClr val="accent1"/>
+          </a:lnRef>
+          <a:fillRef idx="3">
+            <a:schemeClr val="accent1"/>
+          </a:fillRef>
+          <a:effectRef idx="2">
+            <a:schemeClr val="accent1"/>
+          </a:effectRef>
+          <a:fontRef idx="minor">
+            <a:schemeClr val="lt1"/>
+          </a:fontRef>
+        </p:style>
+        <p:txBody>
+          <a:bodyPr rtlCol="0" anchor="ctr"/>
+          <a:lstStyle/>
+          <a:p>
+            <a:pPr algn="ctr"/>
+          </a:p>
+        </p:txBody>
+      </p:sp>
+      <p:sp>
+        <p:nvSpPr>
+          <p:cNvPr id="13" name="TextBox 12"/>
+          <p:cNvSpPr txBox="1"/>
+          <p:nvPr/>
+        </p:nvSpPr>
+        <p:spPr>
+          <a:xfrm>
+            <a:off x="1353312" y="5740146"/>
             <a:ext cx="15947136" cy="402336"/>
           </a:xfrm>
           <a:prstGeom prst="rect">
@@ -2302,7 +2385,90 @@
                 </a:solidFill>
                 <a:latin typeface="Arial"/>
               </a:rPr>
-              <a:t>Still open: this layout has very little per-layer compute, so whether pipelining also helps at real scale is unmeasured.</a:t>
+              <a:t>It also explains the old 28%: seven layers at two per block gives 28.6%, which is what we had measured.</a:t>
+            </a:r>
+          </a:p>
+        </p:txBody>
+      </p:sp>
+      <p:sp>
+        <p:nvSpPr>
+          <p:cNvPr id="14" name="dot"/>
+          <p:cNvSpPr/>
+          <p:nvPr/>
+        </p:nvSpPr>
+        <p:spPr>
+          <a:xfrm>
+            <a:off x="987552" y="6581394"/>
+            <a:ext cx="109728" cy="109728"/>
+          </a:xfrm>
+          <a:prstGeom prst="ellipse">
+            <a:avLst/>
+          </a:prstGeom>
+          <a:solidFill>
+            <a:srgbClr val="6D28D9"/>
+          </a:solidFill>
+          <a:ln>
+            <a:noFill/>
+          </a:ln>
+          <a:effectLst/>
+        </p:spPr>
+        <p:style>
+          <a:lnRef idx="1">
+            <a:schemeClr val="accent1"/>
+          </a:lnRef>
+          <a:fillRef idx="3">
+            <a:schemeClr val="accent1"/>
+          </a:fillRef>
+          <a:effectRef idx="2">
+            <a:schemeClr val="accent1"/>
+          </a:effectRef>
+          <a:fontRef idx="minor">
+            <a:schemeClr val="lt1"/>
+          </a:fontRef>
+        </p:style>
+        <p:txBody>
+          <a:bodyPr rtlCol="0" anchor="ctr"/>
+          <a:lstStyle/>
+          <a:p>
+            <a:pPr algn="ctr"/>
+          </a:p>
+        </p:txBody>
+      </p:sp>
+      <p:sp>
+        <p:nvSpPr>
+          <p:cNvPr id="15" name="TextBox 14"/>
+          <p:cNvSpPr txBox="1"/>
+          <p:nvPr/>
+        </p:nvSpPr>
+        <p:spPr>
+          <a:xfrm>
+            <a:off x="1353312" y="6453378"/>
+            <a:ext cx="15947136" cy="804672"/>
+          </a:xfrm>
+          <a:prstGeom prst="rect">
+            <a:avLst/>
+          </a:prstGeom>
+          <a:noFill/>
+        </p:spPr>
+        <p:txBody>
+          <a:bodyPr wrap="square" lIns="0" rIns="0" tIns="0" bIns="0" anchor="t">
+            <a:spAutoFit/>
+          </a:bodyPr>
+          <a:lstStyle/>
+          <a:p>
+            <a:pPr algn="l">
+              <a:lnSpc>
+                <a:spcPct val="132000"/>
+              </a:lnSpc>
+            </a:pPr>
+            <a:r>
+              <a:rPr sz="2400" b="0" u="none" i="0">
+                <a:solidFill>
+                  <a:srgbClr val="18181B"/>
+                </a:solidFill>
+                <a:latin typeface="Arial"/>
+              </a:rPr>
+              <a:t>A stale divisor made absolute per-token figures about five times too low. Ratios hold, but throughput baselines need re-checking.</a:t>
             </a:r>
           </a:p>
         </p:txBody>
@@ -6037,7 +6203,7 @@
                 </a:solidFill>
                 <a:latin typeface="Arial"/>
               </a:rPr>
-              <a:t>Continuous batching: M1 builds the substrate, but running requests concurrently needs ingress, egress and a scheduler reworked. Which milestone owns it?</a:t>
+              <a:t>The cluster was available all along, so the standing assumption that it was down was stale. Does M0's transport work restart now?</a:t>
             </a:r>
           </a:p>
         </p:txBody>
@@ -6095,7 +6261,7 @@
         <p:spPr>
           <a:xfrm>
             <a:off x="1353312" y="3600450"/>
-            <a:ext cx="15947136" cy="804672"/>
+            <a:ext cx="15947136" cy="402336"/>
           </a:xfrm>
           <a:prstGeom prst="rect">
             <a:avLst/>
@@ -6120,7 +6286,7 @@
                 </a:solidFill>
                 <a:latin typeface="Arial"/>
               </a:rPr>
-              <a:t>Ragged batch, meaning lanes sitting at different sequence positions. M1 declined it, but continuous batching needs it. Do we cost it on its own?</a:t>
+              <a:t>Device runs are timing-only, with no correctness gate at device scale. When do we add one?</a:t>
             </a:r>
           </a:p>
         </p:txBody>
@@ -6133,7 +6299,7 @@
         </p:nvSpPr>
         <p:spPr>
           <a:xfrm>
-            <a:off x="987552" y="4844033"/>
+            <a:off x="987552" y="4441698"/>
             <a:ext cx="109728" cy="109728"/>
           </a:xfrm>
           <a:prstGeom prst="ellipse">
@@ -6177,8 +6343,8 @@
         </p:nvSpPr>
         <p:spPr>
           <a:xfrm>
-            <a:off x="1353312" y="4716018"/>
-            <a:ext cx="15947136" cy="402336"/>
+            <a:off x="1353312" y="4313682"/>
+            <a:ext cx="15947136" cy="804672"/>
           </a:xfrm>
           <a:prstGeom prst="rect">
             <a:avLst/>
@@ -6203,7 +6369,7 @@
                 </a:solidFill>
                 <a:latin typeface="Arial"/>
               </a:rPr>
-              <a:t>Do we run the control-plane comparison inside M1, or on a branch forked after M1-S2?</a:t>
+              <a:t>A forced token at 56 to 67 microseconds looks faster than our recorded prefill rate. A like-for-like run would settle force-decode against ship-to-prefill.</a:t>
             </a:r>
           </a:p>
         </p:txBody>
@@ -6261,7 +6427,7 @@
         <p:spPr>
           <a:xfrm>
             <a:off x="1353312" y="5429250"/>
-            <a:ext cx="15947136" cy="402336"/>
+            <a:ext cx="15947136" cy="804672"/>
           </a:xfrm>
           <a:prstGeom prst="rect">
             <a:avLst/>
@@ -6286,7 +6452,7 @@
                 </a:solidFill>
                 <a:latin typeface="Arial"/>
               </a:rPr>
-              <a:t>Measuring real-scale pipelining needs a compute-heavy configuration. Is it worth the wafer time?</a:t>
+              <a:t>Continuous batching: M1 builds the substrate, but running requests concurrently needs ingress, egress and a scheduler reworked. Which milestone owns it?</a:t>
             </a:r>
           </a:p>
         </p:txBody>
@@ -6299,7 +6465,7 @@
         </p:nvSpPr>
         <p:spPr>
           <a:xfrm>
-            <a:off x="987552" y="6270498"/>
+            <a:off x="987552" y="6672833"/>
             <a:ext cx="109728" cy="109728"/>
           </a:xfrm>
           <a:prstGeom prst="ellipse">
@@ -6343,7 +6509,7 @@
         </p:nvSpPr>
         <p:spPr>
           <a:xfrm>
-            <a:off x="1353312" y="6142482"/>
+            <a:off x="1353312" y="6544818"/>
             <a:ext cx="15947136" cy="402336"/>
           </a:xfrm>
           <a:prstGeom prst="rect">
@@ -6369,7 +6535,90 @@
                 </a:solidFill>
                 <a:latin typeface="Arial"/>
               </a:rPr>
-              <a:t>The CS-3 cluster is down, so M0's transport work stays parked. M1 runs in simulation meanwhile.</a:t>
+              <a:t>Ragged batch, meaning lanes at different sequence positions. M1 declined it, but continuous batching needs it.</a:t>
+            </a:r>
+          </a:p>
+        </p:txBody>
+      </p:sp>
+      <p:sp>
+        <p:nvSpPr>
+          <p:cNvPr id="14" name="dot"/>
+          <p:cNvSpPr/>
+          <p:nvPr/>
+        </p:nvSpPr>
+        <p:spPr>
+          <a:xfrm>
+            <a:off x="987552" y="7386066"/>
+            <a:ext cx="109728" cy="109728"/>
+          </a:xfrm>
+          <a:prstGeom prst="ellipse">
+            <a:avLst/>
+          </a:prstGeom>
+          <a:solidFill>
+            <a:srgbClr val="6D28D9"/>
+          </a:solidFill>
+          <a:ln>
+            <a:noFill/>
+          </a:ln>
+          <a:effectLst/>
+        </p:spPr>
+        <p:style>
+          <a:lnRef idx="1">
+            <a:schemeClr val="accent1"/>
+          </a:lnRef>
+          <a:fillRef idx="3">
+            <a:schemeClr val="accent1"/>
+          </a:fillRef>
+          <a:effectRef idx="2">
+            <a:schemeClr val="accent1"/>
+          </a:effectRef>
+          <a:fontRef idx="minor">
+            <a:schemeClr val="lt1"/>
+          </a:fontRef>
+        </p:style>
+        <p:txBody>
+          <a:bodyPr rtlCol="0" anchor="ctr"/>
+          <a:lstStyle/>
+          <a:p>
+            <a:pPr algn="ctr"/>
+          </a:p>
+        </p:txBody>
+      </p:sp>
+      <p:sp>
+        <p:nvSpPr>
+          <p:cNvPr id="15" name="TextBox 14"/>
+          <p:cNvSpPr txBox="1"/>
+          <p:nvPr/>
+        </p:nvSpPr>
+        <p:spPr>
+          <a:xfrm>
+            <a:off x="1353312" y="7258050"/>
+            <a:ext cx="15947136" cy="402336"/>
+          </a:xfrm>
+          <a:prstGeom prst="rect">
+            <a:avLst/>
+          </a:prstGeom>
+          <a:noFill/>
+        </p:spPr>
+        <p:txBody>
+          <a:bodyPr wrap="square" lIns="0" rIns="0" tIns="0" bIns="0" anchor="t">
+            <a:spAutoFit/>
+          </a:bodyPr>
+          <a:lstStyle/>
+          <a:p>
+            <a:pPr algn="l">
+              <a:lnSpc>
+                <a:spcPct val="132000"/>
+              </a:lnSpc>
+            </a:pPr>
+            <a:r>
+              <a:rPr sz="2400" b="0" u="none" i="0">
+                <a:solidFill>
+                  <a:srgbClr val="18181B"/>
+                </a:solidFill>
+                <a:latin typeface="Arial"/>
+              </a:rPr>
+              <a:t>Do we run the control-plane comparison inside M1, or on a branch forked after M1-S2?</a:t>
             </a:r>
           </a:p>
         </p:txBody>
@@ -7530,7 +7779,7 @@
         <p:spPr>
           <a:xfrm>
             <a:off x="4250131" y="4139946"/>
-            <a:ext cx="2896819" cy="653796"/>
+            <a:ext cx="2896819" cy="326898"/>
           </a:xfrm>
           <a:prstGeom prst="rect">
             <a:avLst/>
@@ -7555,7 +7804,7 @@
                 </a:solidFill>
                 <a:latin typeface="Arial"/>
               </a:rPr>
-              <a:t>KV transport, waiting on the cluster</a:t>
+              <a:t>KV transport, still to build</a:t>
             </a:r>
           </a:p>
         </p:txBody>
@@ -8217,7 +8466,7 @@
                 </a:solidFill>
                 <a:latin typeface="Arial"/>
               </a:rPr>
-              <a:t>Force-decode (S6b) was designed, built in three stages and verified in simulation, then merged.</a:t>
+              <a:t>Force-decode was re-measured on the wafer and the conclusion reversed: the win is layer overlap, not skipped work.</a:t>
             </a:r>
           </a:p>
         </p:txBody>
@@ -8275,7 +8524,7 @@
         <p:spPr>
           <a:xfrm>
             <a:off x="1353312" y="3198113"/>
-            <a:ext cx="15947136" cy="804672"/>
+            <a:ext cx="15947136" cy="402336"/>
           </a:xfrm>
           <a:prstGeom prst="rect">
             <a:avLst/>
@@ -8300,7 +8549,7 @@
                 </a:solidFill>
                 <a:latin typeface="Arial"/>
               </a:rPr>
-              <a:t>That closes S6, so M0's reuse line is complete: decode retain, prefill warm-start and force-decode all sit on one branch.</a:t>
+              <a:t>A forced token costs about 12% of a plain one, roughly 8.5 times cheaper, and that holds across a 15x context range.</a:t>
             </a:r>
           </a:p>
         </p:txBody>
@@ -8313,7 +8562,7 @@
         </p:nvSpPr>
         <p:spPr>
           <a:xfrm>
-            <a:off x="987552" y="4441697"/>
+            <a:off x="987552" y="4039361"/>
             <a:ext cx="109728" cy="109728"/>
           </a:xfrm>
           <a:prstGeom prst="ellipse">
@@ -8357,7 +8606,7 @@
         </p:nvSpPr>
         <p:spPr>
           <a:xfrm>
-            <a:off x="1353312" y="4313681"/>
+            <a:off x="1353312" y="3911346"/>
             <a:ext cx="15947136" cy="402336"/>
           </a:xfrm>
           <a:prstGeom prst="rect">
@@ -8383,7 +8632,7 @@
                 </a:solidFill>
                 <a:latin typeface="Arial"/>
               </a:rPr>
-              <a:t>Two device sweeps finished on real silicon: prefill at a 16,384-token prompt and decode at a 4,096-token context.</a:t>
+              <a:t>S6b merged, which closes S6, so M0's reuse line is complete on a single branch.</a:t>
             </a:r>
           </a:p>
         </p:txBody>
@@ -8396,7 +8645,7 @@
         </p:nvSpPr>
         <p:spPr>
           <a:xfrm>
-            <a:off x="987552" y="5154929"/>
+            <a:off x="987552" y="4752594"/>
             <a:ext cx="109728" cy="109728"/>
           </a:xfrm>
           <a:prstGeom prst="ellipse">
@@ -8440,7 +8689,7 @@
         </p:nvSpPr>
         <p:spPr>
           <a:xfrm>
-            <a:off x="1353312" y="5026914"/>
+            <a:off x="1353312" y="4624578"/>
             <a:ext cx="15947136" cy="402336"/>
           </a:xfrm>
           <a:prstGeom prst="rect">
@@ -8466,7 +8715,7 @@
                 </a:solidFill>
                 <a:latin typeface="Arial"/>
               </a:rPr>
-              <a:t>M1's slot contract was reviewed and approved, and the first subtask is already built and verified in simulation.</a:t>
+              <a:t>Two more device sweeps landed: prefill at a 16,384-token prompt and decode at a 4,096-token context.</a:t>
             </a:r>
           </a:p>
         </p:txBody>
@@ -8479,7 +8728,7 @@
         </p:nvSpPr>
         <p:spPr>
           <a:xfrm>
-            <a:off x="987552" y="5868162"/>
+            <a:off x="987552" y="5465826"/>
             <a:ext cx="109728" cy="109728"/>
           </a:xfrm>
           <a:prstGeom prst="ellipse">
@@ -8523,8 +8772,8 @@
         </p:nvSpPr>
         <p:spPr>
           <a:xfrm>
-            <a:off x="1353312" y="5740146"/>
-            <a:ext cx="15947136" cy="804672"/>
+            <a:off x="1353312" y="5337810"/>
+            <a:ext cx="15947136" cy="402336"/>
           </a:xfrm>
           <a:prstGeom prst="rect">
             <a:avLst/>
@@ -8549,7 +8798,7 @@
                 </a:solidFill>
                 <a:latin typeface="Arial"/>
               </a:rPr>
-              <a:t>Building it reversed two things the contract had assumed, so the design is now shaped by code rather than by argument.</a:t>
+              <a:t>M1's slot contract was approved and its first subtask is already built and verified in simulation.</a:t>
             </a:r>
           </a:p>
         </p:txBody>
@@ -8562,7 +8811,7 @@
         </p:nvSpPr>
         <p:spPr>
           <a:xfrm>
-            <a:off x="987552" y="6983729"/>
+            <a:off x="987552" y="6179058"/>
             <a:ext cx="109728" cy="109728"/>
           </a:xfrm>
           <a:prstGeom prst="ellipse">
@@ -8606,7 +8855,7 @@
         </p:nvSpPr>
         <p:spPr>
           <a:xfrm>
-            <a:off x="1353312" y="6855714"/>
+            <a:off x="1353312" y="6051042"/>
             <a:ext cx="15947136" cy="402336"/>
           </a:xfrm>
           <a:prstGeom prst="rect">
@@ -8632,7 +8881,7 @@
                 </a:solidFill>
                 <a:latin typeface="Arial"/>
               </a:rPr>
-              <a:t>M2 grew from a single cost model into a cluster of coupled architecture questions, each to be settled by a benchmark.</a:t>
+              <a:t>M2 grew from a single cost model into a cluster of coupled architecture questions.</a:t>
             </a:r>
           </a:p>
         </p:txBody>
@@ -9246,7 +9495,7 @@
         <p:spPr>
           <a:xfrm>
             <a:off x="1353312" y="4716018"/>
-            <a:ext cx="15947136" cy="402336"/>
+            <a:ext cx="15947136" cy="804672"/>
           </a:xfrm>
           <a:prstGeom prst="rect">
             <a:avLst/>
@@ -9271,7 +9520,7 @@
                 </a:solidFill>
                 <a:latin typeface="Arial"/>
               </a:rPr>
-              <a:t>New text can be appended to a kept context by force-decoding it. Verified in simulation only so far.</a:t>
+              <a:t>New text can be appended to a kept context by force-decoding it. Correctness checked in simulation; speed now measured on the wafer.</a:t>
             </a:r>
           </a:p>
         </p:txBody>
@@ -9284,7 +9533,7 @@
         </p:nvSpPr>
         <p:spPr>
           <a:xfrm>
-            <a:off x="987552" y="5557266"/>
+            <a:off x="987552" y="5959601"/>
             <a:ext cx="109728" cy="109728"/>
           </a:xfrm>
           <a:prstGeom prst="ellipse">
@@ -9328,7 +9577,7 @@
         </p:nvSpPr>
         <p:spPr>
           <a:xfrm>
-            <a:off x="1353312" y="5429250"/>
+            <a:off x="1353312" y="5831586"/>
             <a:ext cx="15947136" cy="402336"/>
           </a:xfrm>
           <a:prstGeom prst="rect">
@@ -9489,7 +9738,7 @@
                 </a:solidFill>
                 <a:latin typeface="Arial"/>
               </a:rPr>
-              <a:t>Two sweeps on real silicon, one finding that changed our mind.</a:t>
+              <a:t>Three sweeps on real silicon, and a conclusion we had to reverse.</a:t>
             </a:r>
           </a:p>
         </p:txBody>

</xml_diff>